<commit_message>
Serve the stand-alone app from this repo's GitHub Pages
The try-it site now lives at https://ishmiit.github.io/Sahayak/, built by
scripts/build_tryit.py and published from this repository's gh-pages branch
(check_phone_offline.py against it: 9/9). The new address and its QR code are
in facts_v3.json, the README, demo_day.py, the jury kit, the one-pager and the
keynote deck. Keynote slide 13 no longer says the address is the round-one one;
it now shows that the code, the tests and the file behind every number are
public.

Co-Authored-By: Claude Opus 5.5 <noreply@anthropic.com>
</commit_message>
<xml_diff>
--- a/docs/deck/Sahayak_Keynote_v5.pptx
+++ b/docs/deck/Sahayak_Keynote_v5.pptx
@@ -120,72 +120,72 @@
   <p:extLst>
     <p:ext uri="{521415D9-36F7-43E2-AB2F-B90AF26B5E84}">
       <p14:sectionLst xmlns:p14="http://schemas.microsoft.com/office/powerpoint/2010/main">
-        <p14:section name="The message" id="{8d472981-6266-adad-844a-ff23886c6977}">
+        <p14:section name="The message" id="{a6222779-f308-abc3-24e5-317a21c344fb}">
           <p14:sldIdLst>
             <p14:sldId id="256"/>
           </p14:sldIdLst>
         </p14:section>
-        <p14:section name="Who reads it" id="{e6882cad-a18b-63a8-9b5b-228ff52e6ace}">
+        <p14:section name="Who reads it" id="{01a2b4f3-b88f-6c24-2c0b-47c86fe7bf1b}">
           <p14:sldIdLst>
             <p14:sldId id="257"/>
           </p14:sldIdLst>
         </p14:section>
-        <p14:section name="Every minute" id="{1c5d0156-7611-ba66-19dc-7288ec684683}">
+        <p14:section name="Every minute" id="{c5a144ad-3753-b6e1-7cc2-edf807ff1687}">
           <p14:sldIdLst>
             <p14:sldId id="258"/>
           </p14:sldIdLst>
         </p14:section>
-        <p14:section name="Introducing Sahayak" id="{645c556a-38c6-34de-8109-bb43589b12d2}">
+        <p14:section name="Introducing Sahayak" id="{748a1465-4b63-62a8-93bd-28d0fc4c4a17}">
           <p14:sldIdLst>
             <p14:sldId id="259"/>
           </p14:sldIdLst>
         </p14:section>
-        <p14:section name="It tells her why" id="{bd1d3746-0f4d-70bc-bdb6-bc7d1ba78f52}">
+        <p14:section name="It tells her why" id="{aaa5e9c8-c7eb-e089-50ad-2ee3e5fa4fe1}">
           <p14:sldIdLst>
             <p14:sldId id="260"/>
           </p14:sldIdLst>
         </p14:section>
-        <p14:section name="What she is owed" id="{5aa3a671-5df9-c12d-1498-3f25e2b7a806}">
+        <p14:section name="What she is owed" id="{20da63b6-555e-cfa9-3031-05d1591ef64f}">
           <p14:sldIdLst>
             <p14:sldId id="261"/>
           </p14:sldIdLst>
         </p14:section>
-        <p14:section name="Try it" id="{a56de404-9e00-7f42-de9f-7d72ab21b9c6}">
+        <p14:section name="Try it" id="{b6aec84f-9fd0-39a7-721c-dca1f77e5055}">
           <p14:sldIdLst>
             <p14:sldId id="262"/>
           </p14:sldIdLst>
         </p14:section>
-        <p14:section name="How it works" id="{a08eb78e-1f46-62cd-e9e5-ec763e7bcdc7}">
+        <p14:section name="How it works" id="{9064523b-ed93-f44a-6848-069770d36660}">
           <p14:sldIdLst>
             <p14:sldId id="263"/>
           </p14:sldIdLst>
         </p14:section>
-        <p14:section name="Why rules decide" id="{fc61ff12-4317-5534-2d1f-a945b980ac59}">
+        <p14:section name="Why rules decide" id="{12520189-5f56-fa34-1531-6bfd96cee726}">
           <p14:sldIdLst>
             <p14:sldId id="264"/>
           </p14:sldIdLst>
         </p14:section>
-        <p14:section name="The honest number" id="{802a517e-4355-1c3f-8286-435a5f13b7eb}">
+        <p14:section name="The honest number" id="{bd11d996-d301-54b2-9666-8a69680abc1a}">
           <p14:sldIdLst>
             <p14:sldId id="265"/>
           </p14:sldIdLst>
         </p14:section>
-        <p14:section name="The pilot" id="{05f359fd-4963-2a6f-5fa1-dec2863c7006}">
+        <p14:section name="The pilot" id="{d9880d17-cea6-3832-1eaf-23655f6685aa}">
           <p14:sldIdLst>
             <p14:sldId id="266"/>
           </p14:sldIdLst>
         </p14:section>
-        <p14:section name="The ask" id="{586550d0-9d92-77e7-4e4d-a1b47442114c}">
+        <p14:section name="The ask" id="{8c3c6461-a2d6-b74c-6855-c5d41790f95d}">
           <p14:sldIdLst>
             <p14:sldId id="267"/>
           </p14:sldIdLst>
         </p14:section>
-        <p14:section name="One more thing" id="{68fe81f6-3627-dd46-df82-ed7fbcba0f39}">
+        <p14:section name="One more thing" id="{ae3bc636-ca73-809c-a64c-0c4f0798be47}">
           <p14:sldIdLst>
             <p14:sldId id="268"/>
           </p14:sldIdLst>
         </p14:section>
-        <p14:section name="Someone to ask" id="{2060baa0-e72e-850a-3917-d0bef86d81c7}">
+        <p14:section name="Someone to ask" id="{4faaa1ce-b481-ee58-8c5c-c1dd9a0cfa18}">
           <p14:sldIdLst>
             <p14:sldId id="269"/>
           </p14:sldIdLst>
@@ -960,9 +960,9 @@
           <a:p>
             <a:r>
               <a:rPr lang="en-US" dirty="0"/>
-              <a:t>SHOW: Round one: a clickable mock-up. Today: the real thing. A phone in airplane mode.
+              <a:t>SHOW: Everything you saw today is public. A card lists the result file behind each number.
 DO: Click. Pause. Take one step toward the jury. (about 2 s)
-ISHMIIT: And, one more thing. The address you scanned is the one we gave you in round one. Back then, it opened a mock-up. Today, it opens the real Sahayak. And it works in airplane mode.</a:t>
+ISHMIIT: And, one more thing. Everything you’ve seen today is public. The code, the tests, and the file behind every number on these slides. Anyone can check our work. We’d like you to.</a:t>
             </a:r>
             <a:endParaRPr lang="en-US" dirty="0"/>
           </a:p>
@@ -4417,7 +4417,7 @@
         <p:spPr>
           <a:xfrm>
             <a:off x="822960" y="1691640"/>
-            <a:ext cx="7315200" cy="548640"/>
+            <a:ext cx="5852160" cy="548640"/>
           </a:xfrm>
           <a:prstGeom prst="rect">
             <a:avLst/>
@@ -4441,7 +4441,7 @@
                 <a:ea typeface="Arial" pitchFamily="34" charset="-122"/>
                 <a:cs typeface="Arial" pitchFamily="34" charset="-120"/>
               </a:rPr>
-              <a:t>Round one: a clickable mock-up.</a:t>
+              <a:t>Everything you saw today</a:t>
             </a:r>
             <a:endParaRPr lang="en-US" sz="2800" dirty="0"/>
           </a:p>
@@ -4456,7 +4456,7 @@
         <p:spPr>
           <a:xfrm>
             <a:off x="822960" y="2286000"/>
-            <a:ext cx="7498080" cy="1005840"/>
+            <a:ext cx="5852160" cy="1005840"/>
           </a:xfrm>
           <a:prstGeom prst="rect">
             <a:avLst/>
@@ -4472,7 +4472,7 @@
               <a:buNone/>
             </a:pPr>
             <a:r>
-              <a:rPr lang="en-US" sz="5200" b="1" dirty="0">
+              <a:rPr lang="en-US" sz="6000" b="1" dirty="0">
                 <a:solidFill>
                   <a:srgbClr val="F5F5F7"/>
                 </a:solidFill>
@@ -4480,9 +4480,9 @@
                 <a:ea typeface="Arial" pitchFamily="34" charset="-122"/>
                 <a:cs typeface="Arial" pitchFamily="34" charset="-120"/>
               </a:rPr>
-              <a:t>Today: the real thing.</a:t>
-            </a:r>
-            <a:endParaRPr lang="en-US" sz="5200" dirty="0"/>
+              <a:t>is public.</a:t>
+            </a:r>
+            <a:endParaRPr lang="en-US" sz="6000" dirty="0"/>
           </a:p>
         </p:txBody>
       </p:sp>
@@ -4495,7 +4495,7 @@
         <p:spPr>
           <a:xfrm>
             <a:off x="822960" y="3611880"/>
-            <a:ext cx="6583680" cy="0"/>
+            <a:ext cx="5577840" cy="0"/>
           </a:xfrm>
           <a:prstGeom prst="line">
             <a:avLst/>
@@ -4518,7 +4518,7 @@
         <p:spPr>
           <a:xfrm>
             <a:off x="822960" y="3712464"/>
-            <a:ext cx="6583680" cy="530352"/>
+            <a:ext cx="5577840" cy="530352"/>
           </a:xfrm>
           <a:prstGeom prst="rect">
             <a:avLst/>
@@ -4542,21 +4542,7 @@
                 <a:ea typeface="Arial" pitchFamily="34" charset="-122"/>
                 <a:cs typeface="Arial" pitchFamily="34" charset="-120"/>
               </a:rPr>
-              <a:t>Same address</a:t>
-            </a:r>
-            <a:pPr indent="0" marL="0">
-              <a:buNone/>
-            </a:pPr>
-            <a:r>
-              <a:rPr lang="en-US" sz="2400" dirty="0">
-                <a:solidFill>
-                  <a:srgbClr val="A1A1A6"/>
-                </a:solidFill>
-                <a:latin typeface="Arial" pitchFamily="34" charset="0"/>
-                <a:ea typeface="Arial" pitchFamily="34" charset="-122"/>
-                <a:cs typeface="Arial" pitchFamily="34" charset="-120"/>
-              </a:rPr>
-              <a:t> you just scanned.</a:t>
+              <a:t>The code. The tests.</a:t>
             </a:r>
             <a:endParaRPr lang="en-US" sz="2400" dirty="0"/>
           </a:p>
@@ -4571,7 +4557,7 @@
         <p:spPr>
           <a:xfrm>
             <a:off x="822960" y="4270248"/>
-            <a:ext cx="6583680" cy="0"/>
+            <a:ext cx="5577840" cy="0"/>
           </a:xfrm>
           <a:prstGeom prst="line">
             <a:avLst/>
@@ -4594,7 +4580,7 @@
         <p:spPr>
           <a:xfrm>
             <a:off x="822960" y="4370832"/>
-            <a:ext cx="6583680" cy="530352"/>
+            <a:ext cx="5577840" cy="530352"/>
           </a:xfrm>
           <a:prstGeom prst="rect">
             <a:avLst/>
@@ -4618,39 +4604,572 @@
                 <a:ea typeface="Arial" pitchFamily="34" charset="-122"/>
                 <a:cs typeface="Arial" pitchFamily="34" charset="-120"/>
               </a:rPr>
-              <a:t>Works in airplane mode.</a:t>
+              <a:t>The file behind every number.</a:t>
             </a:r>
             <a:endParaRPr lang="en-US" sz="2400" dirty="0"/>
           </a:p>
         </p:txBody>
       </p:sp>
-      <p:pic>
-        <p:nvPicPr>
-          <p:cNvPr id="9" name="Sahayak on a phone with no internet" descr="Screenshot: Sahayak on a phone with no internet">    </p:cNvPr>
-          <p:cNvPicPr>
-            <a:picLocks noChangeAspect="1"/>
-          </p:cNvPicPr>
-          <p:nvPr/>
-        </p:nvPicPr>
-        <p:blipFill>
-          <a:blip r:embed="rId1"/>
-          <a:stretch>
-            <a:fillRect/>
-          </a:stretch>
-        </p:blipFill>
-        <p:spPr>
-          <a:xfrm>
-            <a:off x="8503920" y="594360"/>
-            <a:ext cx="2715748" cy="5669280"/>
-          </a:xfrm>
-          <a:prstGeom prst="rect">
-            <a:avLst/>
-          </a:prstGeom>
-        </p:spPr>
-      </p:pic>
-      <p:sp>
-        <p:nvSpPr>
-          <p:cNvPr id="10" name="source"/>
+      <p:sp>
+        <p:nvSpPr>
+          <p:cNvPr id="9" name="repo card"/>
+          <p:cNvSpPr/>
+          <p:nvPr/>
+        </p:nvSpPr>
+        <p:spPr>
+          <a:xfrm>
+            <a:off x="6903720" y="1097280"/>
+            <a:ext cx="4480560" cy="4343400"/>
+          </a:xfrm>
+          <a:prstGeom prst="roundRect">
+            <a:avLst>
+              <a:gd name="adj" fmla="val 3789"/>
+            </a:avLst>
+          </a:prstGeom>
+          <a:solidFill>
+            <a:srgbClr val="161618"/>
+          </a:solidFill>
+          <a:ln w="12700">
+            <a:solidFill>
+              <a:srgbClr val="2C2C30"/>
+            </a:solidFill>
+            <a:prstDash val="solid"/>
+          </a:ln>
+        </p:spPr>
+      </p:sp>
+      <p:sp>
+        <p:nvSpPr>
+          <p:cNvPr id="10" name="repo"/>
+          <p:cNvSpPr txBox="1"/>
+          <p:nvPr/>
+        </p:nvSpPr>
+        <p:spPr>
+          <a:xfrm>
+            <a:off x="7223760" y="1371600"/>
+            <a:ext cx="3931920" cy="365760"/>
+          </a:xfrm>
+          <a:prstGeom prst="rect">
+            <a:avLst/>
+          </a:prstGeom>
+          <a:noFill/>
+          <a:ln/>
+        </p:spPr>
+        <p:txBody>
+          <a:bodyPr wrap="square" lIns="0" tIns="0" rIns="0" bIns="0" rtlCol="0" anchor="t"/>
+          <a:lstStyle/>
+          <a:p>
+            <a:pPr indent="0" marL="0">
+              <a:buNone/>
+            </a:pPr>
+            <a:r>
+              <a:rPr lang="en-US" sz="1600" b="1" dirty="0">
+                <a:solidFill>
+                  <a:srgbClr val="6FA8FF"/>
+                </a:solidFill>
+                <a:latin typeface="Arial" pitchFamily="34" charset="0"/>
+                <a:ea typeface="Arial" pitchFamily="34" charset="-122"/>
+                <a:cs typeface="Arial" pitchFamily="34" charset="-120"/>
+              </a:rPr>
+              <a:t>github.com/ishmiit/Sahayak</a:t>
+            </a:r>
+            <a:endParaRPr lang="en-US" sz="1600" dirty="0"/>
+          </a:p>
+        </p:txBody>
+      </p:sp>
+      <p:sp>
+        <p:nvSpPr>
+          <p:cNvPr id="11" name="repo rule"/>
+          <p:cNvSpPr/>
+          <p:nvPr/>
+        </p:nvSpPr>
+        <p:spPr>
+          <a:xfrm>
+            <a:off x="7223760" y="1874520"/>
+            <a:ext cx="3840480" cy="0"/>
+          </a:xfrm>
+          <a:prstGeom prst="line">
+            <a:avLst/>
+          </a:prstGeom>
+          <a:noFill/>
+          <a:ln w="9525">
+            <a:solidFill>
+              <a:srgbClr val="3A3A3E"/>
+            </a:solidFill>
+            <a:prstDash val="solid"/>
+          </a:ln>
+        </p:spPr>
+      </p:sp>
+      <p:sp>
+        <p:nvSpPr>
+          <p:cNvPr id="12" name="file 1"/>
+          <p:cNvSpPr txBox="1"/>
+          <p:nvPr/>
+        </p:nvSpPr>
+        <p:spPr>
+          <a:xfrm>
+            <a:off x="7223760" y="2057400"/>
+            <a:ext cx="2377440" cy="365760"/>
+          </a:xfrm>
+          <a:prstGeom prst="rect">
+            <a:avLst/>
+          </a:prstGeom>
+          <a:noFill/>
+          <a:ln/>
+        </p:spPr>
+        <p:txBody>
+          <a:bodyPr wrap="square" lIns="0" tIns="0" rIns="0" bIns="0" rtlCol="0" anchor="ctr"/>
+          <a:lstStyle/>
+          <a:p>
+            <a:pPr indent="0" marL="0">
+              <a:buNone/>
+            </a:pPr>
+            <a:r>
+              <a:rPr lang="en-US" sz="1300" dirty="0">
+                <a:solidFill>
+                  <a:srgbClr val="A1A1A6"/>
+                </a:solidFill>
+                <a:latin typeface="Courier New" pitchFamily="34" charset="0"/>
+                <a:ea typeface="Courier New" pitchFamily="34" charset="-122"/>
+                <a:cs typeface="Courier New" pitchFamily="34" charset="-120"/>
+              </a:rPr>
+              <a:t>public_v0.json</a:t>
+            </a:r>
+            <a:endParaRPr lang="en-US" sz="1300" dirty="0"/>
+          </a:p>
+        </p:txBody>
+      </p:sp>
+      <p:sp>
+        <p:nvSpPr>
+          <p:cNvPr id="13" name="file 1 number"/>
+          <p:cNvSpPr txBox="1"/>
+          <p:nvPr/>
+        </p:nvSpPr>
+        <p:spPr>
+          <a:xfrm>
+            <a:off x="9418320" y="2057400"/>
+            <a:ext cx="1691640" cy="365760"/>
+          </a:xfrm>
+          <a:prstGeom prst="rect">
+            <a:avLst/>
+          </a:prstGeom>
+          <a:noFill/>
+          <a:ln/>
+        </p:spPr>
+        <p:txBody>
+          <a:bodyPr wrap="square" lIns="0" tIns="0" rIns="0" bIns="0" rtlCol="0" anchor="ctr"/>
+          <a:lstStyle/>
+          <a:p>
+            <a:pPr algn="r" indent="0" marL="0">
+              <a:buNone/>
+            </a:pPr>
+            <a:r>
+              <a:rPr lang="en-US" sz="1500" b="1" dirty="0">
+                <a:solidFill>
+                  <a:srgbClr val="F5F5F7"/>
+                </a:solidFill>
+                <a:latin typeface="Arial" pitchFamily="34" charset="0"/>
+                <a:ea typeface="Arial" pitchFamily="34" charset="-122"/>
+                <a:cs typeface="Arial" pitchFamily="34" charset="-120"/>
+              </a:rPr>
+              <a:t>7 in 10</a:t>
+            </a:r>
+            <a:endParaRPr lang="en-US" sz="1500" dirty="0"/>
+          </a:p>
+        </p:txBody>
+      </p:sp>
+      <p:sp>
+        <p:nvSpPr>
+          <p:cNvPr id="14" name="file 2"/>
+          <p:cNvSpPr txBox="1"/>
+          <p:nvPr/>
+        </p:nvSpPr>
+        <p:spPr>
+          <a:xfrm>
+            <a:off x="7223760" y="2587752"/>
+            <a:ext cx="2377440" cy="365760"/>
+          </a:xfrm>
+          <a:prstGeom prst="rect">
+            <a:avLst/>
+          </a:prstGeom>
+          <a:noFill/>
+          <a:ln/>
+        </p:spPr>
+        <p:txBody>
+          <a:bodyPr wrap="square" lIns="0" tIns="0" rIns="0" bIns="0" rtlCol="0" anchor="ctr"/>
+          <a:lstStyle/>
+          <a:p>
+            <a:pPr indent="0" marL="0">
+              <a:buNone/>
+            </a:pPr>
+            <a:r>
+              <a:rPr lang="en-US" sz="1300" dirty="0">
+                <a:solidFill>
+                  <a:srgbClr val="A1A1A6"/>
+                </a:solidFill>
+                <a:latin typeface="Courier New" pitchFamily="34" charset="0"/>
+                <a:ea typeface="Courier New" pitchFamily="34" charset="-122"/>
+                <a:cs typeface="Courier New" pitchFamily="34" charset="-120"/>
+              </a:rPr>
+              <a:t>redteam_v1_blind.json</a:t>
+            </a:r>
+            <a:endParaRPr lang="en-US" sz="1300" dirty="0"/>
+          </a:p>
+        </p:txBody>
+      </p:sp>
+      <p:sp>
+        <p:nvSpPr>
+          <p:cNvPr id="15" name="file 2 number"/>
+          <p:cNvSpPr txBox="1"/>
+          <p:nvPr/>
+        </p:nvSpPr>
+        <p:spPr>
+          <a:xfrm>
+            <a:off x="9418320" y="2587752"/>
+            <a:ext cx="1691640" cy="365760"/>
+          </a:xfrm>
+          <a:prstGeom prst="rect">
+            <a:avLst/>
+          </a:prstGeom>
+          <a:noFill/>
+          <a:ln/>
+        </p:spPr>
+        <p:txBody>
+          <a:bodyPr wrap="square" lIns="0" tIns="0" rIns="0" bIns="0" rtlCol="0" anchor="ctr"/>
+          <a:lstStyle/>
+          <a:p>
+            <a:pPr algn="r" indent="0" marL="0">
+              <a:buNone/>
+            </a:pPr>
+            <a:r>
+              <a:rPr lang="en-US" sz="1500" b="1" dirty="0">
+                <a:solidFill>
+                  <a:srgbClr val="F5F5F7"/>
+                </a:solidFill>
+                <a:latin typeface="Arial" pitchFamily="34" charset="0"/>
+                <a:ea typeface="Arial" pitchFamily="34" charset="-122"/>
+                <a:cs typeface="Arial" pitchFamily="34" charset="-120"/>
+              </a:rPr>
+              <a:t>92 of 103</a:t>
+            </a:r>
+            <a:endParaRPr lang="en-US" sz="1500" dirty="0"/>
+          </a:p>
+        </p:txBody>
+      </p:sp>
+      <p:sp>
+        <p:nvSpPr>
+          <p:cNvPr id="16" name="file 3"/>
+          <p:cNvSpPr txBox="1"/>
+          <p:nvPr/>
+        </p:nvSpPr>
+        <p:spPr>
+          <a:xfrm>
+            <a:off x="7223760" y="3118104"/>
+            <a:ext cx="2377440" cy="365760"/>
+          </a:xfrm>
+          <a:prstGeom prst="rect">
+            <a:avLst/>
+          </a:prstGeom>
+          <a:noFill/>
+          <a:ln/>
+        </p:spPr>
+        <p:txBody>
+          <a:bodyPr wrap="square" lIns="0" tIns="0" rIns="0" bIns="0" rtlCol="0" anchor="ctr"/>
+          <a:lstStyle/>
+          <a:p>
+            <a:pPr indent="0" marL="0">
+              <a:buNone/>
+            </a:pPr>
+            <a:r>
+              <a:rPr lang="en-US" sz="1300" dirty="0">
+                <a:solidFill>
+                  <a:srgbClr val="A1A1A6"/>
+                </a:solidFill>
+                <a:latin typeface="Courier New" pitchFamily="34" charset="0"/>
+                <a:ea typeface="Courier New" pitchFamily="34" charset="-122"/>
+                <a:cs typeface="Courier New" pitchFamily="34" charset="-120"/>
+              </a:rPr>
+              <a:t>scambench_v0_test.json</a:t>
+            </a:r>
+            <a:endParaRPr lang="en-US" sz="1300" dirty="0"/>
+          </a:p>
+        </p:txBody>
+      </p:sp>
+      <p:sp>
+        <p:nvSpPr>
+          <p:cNvPr id="17" name="file 3 number"/>
+          <p:cNvSpPr txBox="1"/>
+          <p:nvPr/>
+        </p:nvSpPr>
+        <p:spPr>
+          <a:xfrm>
+            <a:off x="9418320" y="3118104"/>
+            <a:ext cx="1691640" cy="365760"/>
+          </a:xfrm>
+          <a:prstGeom prst="rect">
+            <a:avLst/>
+          </a:prstGeom>
+          <a:noFill/>
+          <a:ln/>
+        </p:spPr>
+        <p:txBody>
+          <a:bodyPr wrap="square" lIns="0" tIns="0" rIns="0" bIns="0" rtlCol="0" anchor="ctr"/>
+          <a:lstStyle/>
+          <a:p>
+            <a:pPr algn="r" indent="0" marL="0">
+              <a:buNone/>
+            </a:pPr>
+            <a:r>
+              <a:rPr lang="en-US" sz="1500" b="1" dirty="0">
+                <a:solidFill>
+                  <a:srgbClr val="F5F5F7"/>
+                </a:solidFill>
+                <a:latin typeface="Arial" pitchFamily="34" charset="0"/>
+                <a:ea typeface="Arial" pitchFamily="34" charset="-122"/>
+                <a:cs typeface="Arial" pitchFamily="34" charset="-120"/>
+              </a:rPr>
+              <a:t>34 of 37</a:t>
+            </a:r>
+            <a:endParaRPr lang="en-US" sz="1500" dirty="0"/>
+          </a:p>
+        </p:txBody>
+      </p:sp>
+      <p:sp>
+        <p:nvSpPr>
+          <p:cNvPr id="18" name="file 4"/>
+          <p:cNvSpPr txBox="1"/>
+          <p:nvPr/>
+        </p:nvSpPr>
+        <p:spPr>
+          <a:xfrm>
+            <a:off x="7223760" y="3648456"/>
+            <a:ext cx="2377440" cy="365760"/>
+          </a:xfrm>
+          <a:prstGeom prst="rect">
+            <a:avLst/>
+          </a:prstGeom>
+          <a:noFill/>
+          <a:ln/>
+        </p:spPr>
+        <p:txBody>
+          <a:bodyPr wrap="square" lIns="0" tIns="0" rIns="0" bIns="0" rtlCol="0" anchor="ctr"/>
+          <a:lstStyle/>
+          <a:p>
+            <a:pPr indent="0" marL="0">
+              <a:buNone/>
+            </a:pPr>
+            <a:r>
+              <a:rPr lang="en-US" sz="1300" dirty="0">
+                <a:solidFill>
+                  <a:srgbClr val="A1A1A6"/>
+                </a:solidFill>
+                <a:latin typeface="Courier New" pitchFamily="34" charset="0"/>
+                <a:ea typeface="Courier New" pitchFamily="34" charset="-122"/>
+                <a:cs typeface="Courier New" pitchFamily="34" charset="-120"/>
+              </a:rPr>
+              <a:t>llm_baseline.json</a:t>
+            </a:r>
+            <a:endParaRPr lang="en-US" sz="1300" dirty="0"/>
+          </a:p>
+        </p:txBody>
+      </p:sp>
+      <p:sp>
+        <p:nvSpPr>
+          <p:cNvPr id="19" name="file 4 number"/>
+          <p:cNvSpPr txBox="1"/>
+          <p:nvPr/>
+        </p:nvSpPr>
+        <p:spPr>
+          <a:xfrm>
+            <a:off x="9418320" y="3648456"/>
+            <a:ext cx="1691640" cy="365760"/>
+          </a:xfrm>
+          <a:prstGeom prst="rect">
+            <a:avLst/>
+          </a:prstGeom>
+          <a:noFill/>
+          <a:ln/>
+        </p:spPr>
+        <p:txBody>
+          <a:bodyPr wrap="square" lIns="0" tIns="0" rIns="0" bIns="0" rtlCol="0" anchor="ctr"/>
+          <a:lstStyle/>
+          <a:p>
+            <a:pPr algn="r" indent="0" marL="0">
+              <a:buNone/>
+            </a:pPr>
+            <a:r>
+              <a:rPr lang="en-US" sz="1500" b="1" dirty="0">
+                <a:solidFill>
+                  <a:srgbClr val="F5F5F7"/>
+                </a:solidFill>
+                <a:latin typeface="Arial" pitchFamily="34" charset="0"/>
+                <a:ea typeface="Arial" pitchFamily="34" charset="-122"/>
+                <a:cs typeface="Arial" pitchFamily="34" charset="-120"/>
+              </a:rPr>
+              <a:t>21 vs 11</a:t>
+            </a:r>
+            <a:endParaRPr lang="en-US" sz="1500" dirty="0"/>
+          </a:p>
+        </p:txBody>
+      </p:sp>
+      <p:sp>
+        <p:nvSpPr>
+          <p:cNvPr id="20" name="file 5"/>
+          <p:cNvSpPr txBox="1"/>
+          <p:nvPr/>
+        </p:nvSpPr>
+        <p:spPr>
+          <a:xfrm>
+            <a:off x="7223760" y="4178808"/>
+            <a:ext cx="2377440" cy="365760"/>
+          </a:xfrm>
+          <a:prstGeom prst="rect">
+            <a:avLst/>
+          </a:prstGeom>
+          <a:noFill/>
+          <a:ln/>
+        </p:spPr>
+        <p:txBody>
+          <a:bodyPr wrap="square" lIns="0" tIns="0" rIns="0" bIns="0" rtlCol="0" anchor="ctr"/>
+          <a:lstStyle/>
+          <a:p>
+            <a:pPr indent="0" marL="0">
+              <a:buNone/>
+            </a:pPr>
+            <a:r>
+              <a:rPr lang="en-US" sz="1300" dirty="0">
+                <a:solidFill>
+                  <a:srgbClr val="A1A1A6"/>
+                </a:solidFill>
+                <a:latin typeface="Courier New" pitchFamily="34" charset="0"/>
+                <a:ea typeface="Courier New" pitchFamily="34" charset="-122"/>
+                <a:cs typeface="Courier New" pitchFamily="34" charset="-120"/>
+              </a:rPr>
+              <a:t>phone_parity.json</a:t>
+            </a:r>
+            <a:endParaRPr lang="en-US" sz="1300" dirty="0"/>
+          </a:p>
+        </p:txBody>
+      </p:sp>
+      <p:sp>
+        <p:nvSpPr>
+          <p:cNvPr id="21" name="file 5 number"/>
+          <p:cNvSpPr txBox="1"/>
+          <p:nvPr/>
+        </p:nvSpPr>
+        <p:spPr>
+          <a:xfrm>
+            <a:off x="9418320" y="4178808"/>
+            <a:ext cx="1691640" cy="365760"/>
+          </a:xfrm>
+          <a:prstGeom prst="rect">
+            <a:avLst/>
+          </a:prstGeom>
+          <a:noFill/>
+          <a:ln/>
+        </p:spPr>
+        <p:txBody>
+          <a:bodyPr wrap="square" lIns="0" tIns="0" rIns="0" bIns="0" rtlCol="0" anchor="ctr"/>
+          <a:lstStyle/>
+          <a:p>
+            <a:pPr algn="r" indent="0" marL="0">
+              <a:buNone/>
+            </a:pPr>
+            <a:r>
+              <a:rPr lang="en-US" sz="1500" b="1" dirty="0">
+                <a:solidFill>
+                  <a:srgbClr val="F5F5F7"/>
+                </a:solidFill>
+                <a:latin typeface="Arial" pitchFamily="34" charset="0"/>
+                <a:ea typeface="Arial" pitchFamily="34" charset="-122"/>
+                <a:cs typeface="Arial" pitchFamily="34" charset="-120"/>
+              </a:rPr>
+              <a:t>1,841 of 1,841</a:t>
+            </a:r>
+            <a:endParaRPr lang="en-US" sz="1500" dirty="0"/>
+          </a:p>
+        </p:txBody>
+      </p:sp>
+      <p:sp>
+        <p:nvSpPr>
+          <p:cNvPr id="22" name="file 6"/>
+          <p:cNvSpPr txBox="1"/>
+          <p:nvPr/>
+        </p:nvSpPr>
+        <p:spPr>
+          <a:xfrm>
+            <a:off x="7223760" y="4709160"/>
+            <a:ext cx="2377440" cy="365760"/>
+          </a:xfrm>
+          <a:prstGeom prst="rect">
+            <a:avLst/>
+          </a:prstGeom>
+          <a:noFill/>
+          <a:ln/>
+        </p:spPr>
+        <p:txBody>
+          <a:bodyPr wrap="square" lIns="0" tIns="0" rIns="0" bIns="0" rtlCol="0" anchor="ctr"/>
+          <a:lstStyle/>
+          <a:p>
+            <a:pPr indent="0" marL="0">
+              <a:buNone/>
+            </a:pPr>
+            <a:r>
+              <a:rPr lang="en-US" sz="1300" dirty="0">
+                <a:solidFill>
+                  <a:srgbClr val="A1A1A6"/>
+                </a:solidFill>
+                <a:latin typeface="Courier New" pitchFamily="34" charset="0"/>
+                <a:ea typeface="Courier New" pitchFamily="34" charset="-122"/>
+                <a:cs typeface="Courier New" pitchFamily="34" charset="-120"/>
+              </a:rPr>
+              <a:t>facts_v3.json</a:t>
+            </a:r>
+            <a:endParaRPr lang="en-US" sz="1300" dirty="0"/>
+          </a:p>
+        </p:txBody>
+      </p:sp>
+      <p:sp>
+        <p:nvSpPr>
+          <p:cNvPr id="23" name="file 6 number"/>
+          <p:cNvSpPr txBox="1"/>
+          <p:nvPr/>
+        </p:nvSpPr>
+        <p:spPr>
+          <a:xfrm>
+            <a:off x="9418320" y="4709160"/>
+            <a:ext cx="1691640" cy="365760"/>
+          </a:xfrm>
+          <a:prstGeom prst="rect">
+            <a:avLst/>
+          </a:prstGeom>
+          <a:noFill/>
+          <a:ln/>
+        </p:spPr>
+        <p:txBody>
+          <a:bodyPr wrap="square" lIns="0" tIns="0" rIns="0" bIns="0" rtlCol="0" anchor="ctr"/>
+          <a:lstStyle/>
+          <a:p>
+            <a:pPr algn="r" indent="0" marL="0">
+              <a:buNone/>
+            </a:pPr>
+            <a:r>
+              <a:rPr lang="en-US" sz="1500" b="1" dirty="0">
+                <a:solidFill>
+                  <a:srgbClr val="F5F5F7"/>
+                </a:solidFill>
+                <a:latin typeface="Arial" pitchFamily="34" charset="0"/>
+                <a:ea typeface="Arial" pitchFamily="34" charset="-122"/>
+                <a:cs typeface="Arial" pitchFamily="34" charset="-120"/>
+              </a:rPr>
+              <a:t>₹4 lakh a minute</a:t>
+            </a:r>
+            <a:endParaRPr lang="en-US" sz="1500" dirty="0"/>
+          </a:p>
+        </p:txBody>
+      </p:sp>
+      <p:sp>
+        <p:nvSpPr>
+          <p:cNvPr id="24" name="source"/>
           <p:cNvSpPr txBox="1"/>
           <p:nvPr/>
         </p:nvSpPr>
@@ -4681,7 +5200,7 @@
                 <a:ea typeface="Arial" pitchFamily="34" charset="-122"/>
                 <a:cs typeface="Arial" pitchFamily="34" charset="-120"/>
               </a:rPr>
-              <a:t>roshworldwide.github.io/optum-v2 · screenshot: a check on a phone in airplane mode</a:t>
+              <a:t>github.com/ishmiit/Sahayak · results in bench/results, outside numbers in docs/deck/facts_v3.json, each with its source · MIT licence</a:t>
             </a:r>
             <a:endParaRPr lang="en-US" sz="1050" dirty="0"/>
           </a:p>
@@ -7253,7 +7772,7 @@
       </p:sp>
       <p:pic>
         <p:nvPicPr>
-          <p:cNvPr id="3" name="QR code" descr="QR code for https://roshworldwide.github.io/optum-v2/">    </p:cNvPr>
+          <p:cNvPr id="3" name="QR code" descr="QR code for https://ishmiit.github.io/Sahayak/">    </p:cNvPr>
           <p:cNvPicPr>
             <a:picLocks noChangeAspect="1"/>
           </p:cNvPicPr>
@@ -7308,7 +7827,7 @@
                 <a:ea typeface="Arial" pitchFamily="34" charset="-122"/>
                 <a:cs typeface="Arial" pitchFamily="34" charset="-120"/>
               </a:rPr>
-              <a:t>roshworldwide.github.io/optum-v2</a:t>
+              <a:t>ishmiit.github.io/Sahayak</a:t>
             </a:r>
             <a:endParaRPr lang="en-US" sz="1700" dirty="0"/>
           </a:p>

</xml_diff>

<commit_message>
Keynote: no source lines at the bottom of the slides, no ₹39 lakh
- Every slide's small source line is gone (as in Ishmiit's own edit of v5);
  the sources stay in the speaker notes' script and on the script page.
- The pilot slide and speech drop the ₹39 lakh estimate, whose line items
  are not in the repo, for the cost that is checked: ₹25–35k for a CSC's
  computer, once, and every check after that free.

Co-Authored-By: Claude Opus 5.5 <noreply@anthropic.com>
</commit_message>
<xml_diff>
--- a/docs/deck/Sahayak_Keynote_v5.pptx
+++ b/docs/deck/Sahayak_Keynote_v5.pptx
@@ -120,72 +120,72 @@
   <p:extLst>
     <p:ext uri="{521415D9-36F7-43E2-AB2F-B90AF26B5E84}">
       <p14:sectionLst xmlns:p14="http://schemas.microsoft.com/office/powerpoint/2010/main">
-        <p14:section name="The message" id="{f3357668-4d6e-ff7d-3c1e-243e3222afa4}">
+        <p14:section name="The message" id="{49aa679d-7d06-e7a4-acdb-5e0177f5d0ae}">
           <p14:sldIdLst>
             <p14:sldId id="256"/>
           </p14:sldIdLst>
         </p14:section>
-        <p14:section name="Who reads it" id="{e63bdcd9-2913-d9ee-f241-567fa18ef701}">
+        <p14:section name="Who reads it" id="{0dbba5ee-b91b-0f27-eded-5063448cfee9}">
           <p14:sldIdLst>
             <p14:sldId id="257"/>
           </p14:sldIdLst>
         </p14:section>
-        <p14:section name="Every minute" id="{a89f94f2-d4b3-86cb-fe12-b4b85dc11b02}">
+        <p14:section name="Every minute" id="{5d4d0fd2-53ee-b18f-207c-659893ca60b3}">
           <p14:sldIdLst>
             <p14:sldId id="258"/>
           </p14:sldIdLst>
         </p14:section>
-        <p14:section name="Introducing Sahayak" id="{1d03d860-787b-d953-49fc-9b63904cbad0}">
+        <p14:section name="Introducing Sahayak" id="{2ba57fc1-dc5b-3b55-55d6-0f92c2ccff89}">
           <p14:sldIdLst>
             <p14:sldId id="259"/>
           </p14:sldIdLst>
         </p14:section>
-        <p14:section name="It tells her why" id="{cb9c9a6e-3090-b225-b7a0-ea142e59aa7b}">
+        <p14:section name="It tells her why" id="{af4af4fa-5849-913d-adab-f20666263e5e}">
           <p14:sldIdLst>
             <p14:sldId id="260"/>
           </p14:sldIdLst>
         </p14:section>
-        <p14:section name="What she is owed" id="{dd4d9e4b-c9bd-329d-0e17-be0ccdb458de}">
+        <p14:section name="What she is owed" id="{357c36a2-11d7-f1c6-b0bf-0bff62619b8a}">
           <p14:sldIdLst>
             <p14:sldId id="261"/>
           </p14:sldIdLst>
         </p14:section>
-        <p14:section name="How it works" id="{7f1a7c5e-24e5-5504-9841-1c87eb0dd541}">
+        <p14:section name="How it works" id="{245ffadb-cb3c-f3d5-3c05-323d9e3ea5c7}">
           <p14:sldIdLst>
             <p14:sldId id="262"/>
           </p14:sldIdLst>
         </p14:section>
-        <p14:section name="Why rules decide" id="{206d4183-4621-7d3e-04ff-9da9665b7923}">
+        <p14:section name="Why rules decide" id="{7e3e9699-2cbe-bcaa-3798-320df2092ef9}">
           <p14:sldIdLst>
             <p14:sldId id="263"/>
           </p14:sldIdLst>
         </p14:section>
-        <p14:section name="The honest number" id="{4d0f9a1f-dab4-7f98-7a2f-8753f77b2cb7}">
+        <p14:section name="The honest number" id="{e64c4381-1a17-669f-2323-6ef507713b5b}">
           <p14:sldIdLst>
             <p14:sldId id="264"/>
           </p14:sldIdLst>
         </p14:section>
-        <p14:section name="The pilot" id="{534112f2-29d3-b93b-b299-b7dfb18e82b8}">
+        <p14:section name="The pilot" id="{e863f05b-c1a9-a7d8-e61c-15407c6d51cf}">
           <p14:sldIdLst>
             <p14:sldId id="265"/>
           </p14:sldIdLst>
         </p14:section>
-        <p14:section name="The ask" id="{864aa731-9c78-7eb0-1868-87a2d8384dd7}">
+        <p14:section name="The ask" id="{96aae4a8-3d6c-613f-8576-0a33d732b6da}">
           <p14:sldIdLst>
             <p14:sldId id="266"/>
           </p14:sldIdLst>
         </p14:section>
-        <p14:section name="One more thing" id="{a3810166-43b9-a6bc-24db-f9a4eb474489}">
+        <p14:section name="One more thing" id="{833e6b93-8755-a61c-51e3-4ab480cc9373}">
           <p14:sldIdLst>
             <p14:sldId id="267"/>
           </p14:sldIdLst>
         </p14:section>
-        <p14:section name="Someone to ask" id="{7954f74c-1440-85d1-3594-adb9f7c1d7cd}">
+        <p14:section name="Someone to ask" id="{eb4e867c-0156-a046-2e94-4fc271defa35}">
           <p14:sldIdLst>
             <p14:sldId id="268"/>
           </p14:sldIdLst>
         </p14:section>
-        <p14:section name="Try it yourself" id="{cac7665d-4b20-ac8f-c45b-ac25e4a359cf}">
+        <p14:section name="Try it yourself" id="{ace00059-6b9d-48fa-ba6f-3f85600e3dbb}">
           <p14:sldIdLst>
             <p14:sldId id="269"/>
           </p14:sldIdLst>
@@ -685,9 +685,9 @@
           <a:p>
             <a:r>
               <a:rPr lang="en-US" dirty="0"/>
-              <a:t>SHOW: One district: 20 villages, 50 counters, six months, about ₹39 lakh. The next 30 days.
+              <a:t>SHOW: One district: 20 villages, 50 counters, six months, and ₹25–35k for a CSC’s computer, once. The next 30 days.
 DO: Click.
-ISHMIIT: So, the pilot. One district. Twenty villages. Fifty counters. Six months. About thirty-nine lakh rupees, and the biggest share goes to the local operator at each counter.</a:t>
+ISHMIIT: So, the pilot. One district. Twenty villages. Fifty counters. Six months. Each CSC needs one computer, twenty-five to thirty-five thousand rupees, once. After that, every check costs nothing.</a:t>
             </a:r>
             <a:endParaRPr lang="en-US" dirty="0"/>
           </a:p>
@@ -2444,45 +2444,6 @@
           </a:p>
         </p:txBody>
       </p:sp>
-      <p:sp>
-        <p:nvSpPr>
-          <p:cNvPr id="9" name="source"/>
-          <p:cNvSpPr txBox="1"/>
-          <p:nvPr/>
-        </p:nvSpPr>
-        <p:spPr>
-          <a:xfrm>
-            <a:off x="822960" y="6400800"/>
-            <a:ext cx="10545775" cy="256032"/>
-          </a:xfrm>
-          <a:prstGeom prst="rect">
-            <a:avLst/>
-          </a:prstGeom>
-          <a:noFill/>
-          <a:ln/>
-        </p:spPr>
-        <p:txBody>
-          <a:bodyPr wrap="square" lIns="0" tIns="0" rIns="0" bIns="0" rtlCol="0" anchor="t"/>
-          <a:lstStyle/>
-          <a:p>
-            <a:pPr indent="0" marL="0">
-              <a:buNone/>
-            </a:pPr>
-            <a:r>
-              <a:rPr lang="en-US" sz="1050" dirty="0">
-                <a:solidFill>
-                  <a:srgbClr val="6E6E73"/>
-                </a:solidFill>
-                <a:latin typeface="Arial" pitchFamily="34" charset="0"/>
-                <a:ea typeface="Arial" pitchFamily="34" charset="-122"/>
-                <a:cs typeface="Arial" pitchFamily="34" charset="-120"/>
-              </a:rPr>
-              <a:t>A demo message, written by the team in the style of real KYC scams</a:t>
-            </a:r>
-            <a:endParaRPr lang="en-US" sz="1050" dirty="0"/>
-          </a:p>
-        </p:txBody>
-      </p:sp>
     </p:spTree>
   </p:cSld>
   <p:clrMapOvr>
@@ -2945,7 +2906,7 @@
                 <a:ea typeface="Arial" pitchFamily="34" charset="-122"/>
                 <a:cs typeface="Arial" pitchFamily="34" charset="-120"/>
               </a:rPr>
-              <a:t>₹39 lakh</a:t>
+              <a:t>₹25–35k</a:t>
             </a:r>
             <a:endParaRPr lang="en-US" sz="5200" dirty="0"/>
           </a:p>
@@ -2984,7 +2945,7 @@
                 <a:ea typeface="Arial" pitchFamily="34" charset="-122"/>
                 <a:cs typeface="Arial" pitchFamily="34" charset="-120"/>
               </a:rPr>
-              <a:t>estimated</a:t>
+              <a:t>a CSC’s computer, once</a:t>
             </a:r>
             <a:endParaRPr lang="en-US" sz="1800" dirty="0"/>
           </a:p>
@@ -3320,45 +3281,6 @@
               <a:t>A district partner</a:t>
             </a:r>
             <a:endParaRPr lang="en-US" sz="1900" dirty="0"/>
-          </a:p>
-        </p:txBody>
-      </p:sp>
-      <p:sp>
-        <p:nvSpPr>
-          <p:cNvPr id="26" name="source"/>
-          <p:cNvSpPr txBox="1"/>
-          <p:nvPr/>
-        </p:nvSpPr>
-        <p:spPr>
-          <a:xfrm>
-            <a:off x="822960" y="6400800"/>
-            <a:ext cx="10545775" cy="256032"/>
-          </a:xfrm>
-          <a:prstGeom prst="rect">
-            <a:avLst/>
-          </a:prstGeom>
-          <a:noFill/>
-          <a:ln/>
-        </p:spPr>
-        <p:txBody>
-          <a:bodyPr wrap="square" lIns="0" tIns="0" rIns="0" bIns="0" rtlCol="0" anchor="t"/>
-          <a:lstStyle/>
-          <a:p>
-            <a:pPr indent="0" marL="0">
-              <a:buNone/>
-            </a:pPr>
-            <a:r>
-              <a:rPr lang="en-US" sz="1050" dirty="0">
-                <a:solidFill>
-                  <a:srgbClr val="6E6E73"/>
-                </a:solidFill>
-                <a:latin typeface="Arial" pitchFamily="34" charset="0"/>
-                <a:ea typeface="Arial" pitchFamily="34" charset="-122"/>
-                <a:cs typeface="Arial" pitchFamily="34" charset="-120"/>
-              </a:rPr>
-              <a:t>Estimates, not quotes: the team’s line-item budget, 7 Oct 2026 (₹39.2 lakh). At 500 counters, about ₹24,000 a counter a year; the operator’s ₹9,600 is the biggest part.</a:t>
-            </a:r>
-            <a:endParaRPr lang="en-US" sz="1050" dirty="0"/>
           </a:p>
         </p:txBody>
       </p:sp>
@@ -3732,45 +3654,6 @@
           </a:p>
         </p:txBody>
       </p:sp>
-      <p:sp>
-        <p:nvSpPr>
-          <p:cNvPr id="11" name="source"/>
-          <p:cNvSpPr txBox="1"/>
-          <p:nvPr/>
-        </p:nvSpPr>
-        <p:spPr>
-          <a:xfrm>
-            <a:off x="822960" y="6400800"/>
-            <a:ext cx="10545775" cy="256032"/>
-          </a:xfrm>
-          <a:prstGeom prst="rect">
-            <a:avLst/>
-          </a:prstGeom>
-          <a:noFill/>
-          <a:ln/>
-        </p:spPr>
-        <p:txBody>
-          <a:bodyPr wrap="square" lIns="0" tIns="0" rIns="0" bIns="0" rtlCol="0" anchor="t"/>
-          <a:lstStyle/>
-          <a:p>
-            <a:pPr indent="0" marL="0">
-              <a:buNone/>
-            </a:pPr>
-            <a:r>
-              <a:rPr lang="en-US" sz="1050" dirty="0">
-                <a:solidFill>
-                  <a:srgbClr val="6E6E73"/>
-                </a:solidFill>
-                <a:latin typeface="Arial" pitchFamily="34" charset="0"/>
-                <a:ea typeface="Arial" pitchFamily="34" charset="-122"/>
-                <a:cs typeface="Arial" pitchFamily="34" charset="-120"/>
-              </a:rPr>
-              <a:t>6 lakh functional CSCs, 4.7 lakh at gram-panchayat level (MeitY, Mar 2025) · the pilot’s 50 counters: nodes at 20 CSCs, the phone app at 30 bank-agent points</a:t>
-            </a:r>
-            <a:endParaRPr lang="en-US" sz="1050" dirty="0"/>
-          </a:p>
-        </p:txBody>
-      </p:sp>
     </p:spTree>
   </p:cSld>
   <p:clrMapOvr>
@@ -4189,45 +4072,6 @@
           </a:prstGeom>
         </p:spPr>
       </p:pic>
-      <p:sp>
-        <p:nvSpPr>
-          <p:cNvPr id="13" name="source"/>
-          <p:cNvSpPr txBox="1"/>
-          <p:nvPr/>
-        </p:nvSpPr>
-        <p:spPr>
-          <a:xfrm>
-            <a:off x="822960" y="6400800"/>
-            <a:ext cx="10545775" cy="256032"/>
-          </a:xfrm>
-          <a:prstGeom prst="rect">
-            <a:avLst/>
-          </a:prstGeom>
-          <a:noFill/>
-          <a:ln/>
-        </p:spPr>
-        <p:txBody>
-          <a:bodyPr wrap="square" lIns="0" tIns="0" rIns="0" bIns="0" rtlCol="0" anchor="t"/>
-          <a:lstStyle/>
-          <a:p>
-            <a:pPr indent="0" marL="0">
-              <a:buNone/>
-            </a:pPr>
-            <a:r>
-              <a:rPr lang="en-US" sz="1050" dirty="0">
-                <a:solidFill>
-                  <a:srgbClr val="6E6E73"/>
-                </a:solidFill>
-                <a:latin typeface="Arial" pitchFamily="34" charset="0"/>
-                <a:ea typeface="Arial" pitchFamily="34" charset="-122"/>
-                <a:cs typeface="Arial" pitchFamily="34" charset="-120"/>
-              </a:rPr>
-              <a:t>The Learn tab of the same app · every card agrees with Sahayak’s own check (tests/test_game.py) · nothing leaves the phone</a:t>
-            </a:r>
-            <a:endParaRPr lang="en-US" sz="1050" dirty="0"/>
-          </a:p>
-        </p:txBody>
-      </p:sp>
     </p:spTree>
   </p:cSld>
   <p:clrMapOvr>
@@ -4499,45 +4343,6 @@
           </a:p>
         </p:txBody>
       </p:sp>
-      <p:sp>
-        <p:nvSpPr>
-          <p:cNvPr id="8" name="repo"/>
-          <p:cNvSpPr txBox="1"/>
-          <p:nvPr/>
-        </p:nvSpPr>
-        <p:spPr>
-          <a:xfrm>
-            <a:off x="457200" y="6172200"/>
-            <a:ext cx="11277295" cy="274320"/>
-          </a:xfrm>
-          <a:prstGeom prst="rect">
-            <a:avLst/>
-          </a:prstGeom>
-          <a:noFill/>
-          <a:ln/>
-        </p:spPr>
-        <p:txBody>
-          <a:bodyPr wrap="square" lIns="0" tIns="0" rIns="0" bIns="0" rtlCol="0" anchor="t"/>
-          <a:lstStyle/>
-          <a:p>
-            <a:pPr algn="ctr" indent="0" marL="0">
-              <a:buNone/>
-            </a:pPr>
-            <a:r>
-              <a:rPr lang="en-US" sz="1200" dirty="0">
-                <a:solidFill>
-                  <a:srgbClr val="6E6E73"/>
-                </a:solidFill>
-                <a:latin typeface="Arial" pitchFamily="34" charset="0"/>
-                <a:ea typeface="Arial" pitchFamily="34" charset="-122"/>
-                <a:cs typeface="Arial" pitchFamily="34" charset="-120"/>
-              </a:rPr>
-              <a:t>Open source: github.com/ishmiit/Sahayak</a:t>
-            </a:r>
-            <a:endParaRPr lang="en-US" sz="1200" dirty="0"/>
-          </a:p>
-        </p:txBody>
-      </p:sp>
     </p:spTree>
   </p:cSld>
   <p:clrMapOvr>
@@ -5533,45 +5338,6 @@
           </a:p>
         </p:txBody>
       </p:sp>
-      <p:sp>
-        <p:nvSpPr>
-          <p:cNvPr id="7" name="source"/>
-          <p:cNvSpPr txBox="1"/>
-          <p:nvPr/>
-        </p:nvSpPr>
-        <p:spPr>
-          <a:xfrm>
-            <a:off x="822960" y="6400800"/>
-            <a:ext cx="10545775" cy="256032"/>
-          </a:xfrm>
-          <a:prstGeom prst="rect">
-            <a:avLst/>
-          </a:prstGeom>
-          <a:noFill/>
-          <a:ln/>
-        </p:spPr>
-        <p:txBody>
-          <a:bodyPr wrap="square" lIns="0" tIns="0" rIns="0" bIns="0" rtlCol="0" anchor="t"/>
-          <a:lstStyle/>
-          <a:p>
-            <a:pPr indent="0" marL="0">
-              <a:buNone/>
-            </a:pPr>
-            <a:r>
-              <a:rPr lang="en-US" sz="1050" dirty="0">
-                <a:solidFill>
-                  <a:srgbClr val="6E6E73"/>
-                </a:solidFill>
-                <a:latin typeface="Arial" pitchFamily="34" charset="0"/>
-                <a:ea typeface="Arial" pitchFamily="34" charset="-122"/>
-                <a:cs typeface="Arial" pitchFamily="34" charset="-120"/>
-              </a:rPr>
-              <a:t>A demo persona, not a real person</a:t>
-            </a:r>
-            <a:endParaRPr lang="en-US" sz="1050" dirty="0"/>
-          </a:p>
-        </p:txBody>
-      </p:sp>
     </p:spTree>
   </p:cSld>
   <p:clrMapOvr>
@@ -5874,45 +5640,6 @@
               <a:t>of it, from senior citizens</a:t>
             </a:r>
             <a:endParaRPr lang="en-US" sz="1700" dirty="0"/>
-          </a:p>
-        </p:txBody>
-      </p:sp>
-      <p:sp>
-        <p:nvSpPr>
-          <p:cNvPr id="10" name="source"/>
-          <p:cNvSpPr txBox="1"/>
-          <p:nvPr/>
-        </p:nvSpPr>
-        <p:spPr>
-          <a:xfrm>
-            <a:off x="822960" y="6400800"/>
-            <a:ext cx="10545775" cy="256032"/>
-          </a:xfrm>
-          <a:prstGeom prst="rect">
-            <a:avLst/>
-          </a:prstGeom>
-          <a:noFill/>
-          <a:ln/>
-        </p:spPr>
-        <p:txBody>
-          <a:bodyPr wrap="square" lIns="0" tIns="0" rIns="0" bIns="0" rtlCol="0" anchor="t"/>
-          <a:lstStyle/>
-          <a:p>
-            <a:pPr indent="0" marL="0">
-              <a:buNone/>
-            </a:pPr>
-            <a:r>
-              <a:rPr lang="en-US" sz="1050" dirty="0">
-                <a:solidFill>
-                  <a:srgbClr val="6E6E73"/>
-                </a:solidFill>
-                <a:latin typeface="Arial" pitchFamily="34" charset="0"/>
-                <a:ea typeface="Arial" pitchFamily="34" charset="-122"/>
-                <a:cs typeface="Arial" pitchFamily="34" charset="-120"/>
-              </a:rPr>
-              <a:t>MHA / I4C, Rajya Sabha, Feb 2026; seniors: MHA, Rajya Sabha, 5 Aug 2026. Spread evenly over the year, ₹22,495 crore is about ₹7,133 a second.</a:t>
-            </a:r>
-            <a:endParaRPr lang="en-US" sz="1050" dirty="0"/>
           </a:p>
         </p:txBody>
       </p:sp>
@@ -7034,45 +6761,6 @@
           </a:p>
         </p:txBody>
       </p:sp>
-      <p:sp>
-        <p:nvSpPr>
-          <p:cNvPr id="19" name="source"/>
-          <p:cNvSpPr txBox="1"/>
-          <p:nvPr/>
-        </p:nvSpPr>
-        <p:spPr>
-          <a:xfrm>
-            <a:off x="822960" y="6400800"/>
-            <a:ext cx="10545775" cy="256032"/>
-          </a:xfrm>
-          <a:prstGeom prst="rect">
-            <a:avLst/>
-          </a:prstGeom>
-          <a:noFill/>
-          <a:ln/>
-        </p:spPr>
-        <p:txBody>
-          <a:bodyPr wrap="square" lIns="0" tIns="0" rIns="0" bIns="0" rtlCol="0" anchor="t"/>
-          <a:lstStyle/>
-          <a:p>
-            <a:pPr indent="0" marL="0">
-              <a:buNone/>
-            </a:pPr>
-            <a:r>
-              <a:rPr lang="en-US" sz="1050" dirty="0">
-                <a:solidFill>
-                  <a:srgbClr val="6E6E73"/>
-                </a:solidFill>
-                <a:latin typeface="Arial" pitchFamily="34" charset="0"/>
-                <a:ea typeface="Arial" pitchFamily="34" charset="-122"/>
-                <a:cs typeface="Arial" pitchFamily="34" charset="-120"/>
-              </a:rPr>
-              <a:t>Demo persona and SMS written by the team · the app’s answer, on a phone, 14 Oct 2026</a:t>
-            </a:r>
-            <a:endParaRPr lang="en-US" sz="1050" dirty="0"/>
-          </a:p>
-        </p:txBody>
-      </p:sp>
     </p:spTree>
   </p:cSld>
   <p:clrMapOvr>
@@ -7496,48 +7184,9 @@
           </a:p>
         </p:txBody>
       </p:sp>
-      <p:sp>
-        <p:nvSpPr>
-          <p:cNvPr id="12" name="source"/>
-          <p:cNvSpPr txBox="1"/>
-          <p:nvPr/>
-        </p:nvSpPr>
-        <p:spPr>
-          <a:xfrm>
-            <a:off x="822960" y="6400800"/>
-            <a:ext cx="10545775" cy="256032"/>
-          </a:xfrm>
-          <a:prstGeom prst="rect">
-            <a:avLst/>
-          </a:prstGeom>
-          <a:noFill/>
-          <a:ln/>
-        </p:spPr>
-        <p:txBody>
-          <a:bodyPr wrap="square" lIns="0" tIns="0" rIns="0" bIns="0" rtlCol="0" anchor="t"/>
-          <a:lstStyle/>
-          <a:p>
-            <a:pPr indent="0" marL="0">
-              <a:buNone/>
-            </a:pPr>
-            <a:r>
-              <a:rPr lang="en-US" sz="1050" dirty="0">
-                <a:solidFill>
-                  <a:srgbClr val="6E6E73"/>
-                </a:solidFill>
-                <a:latin typeface="Arial" pitchFamily="34" charset="0"/>
-                <a:ea typeface="Arial" pitchFamily="34" charset="-122"/>
-                <a:cs typeface="Arial" pitchFamily="34" charset="-120"/>
-              </a:rPr>
-              <a:t>1.1 of ~6 crore aged 70+ had the card (MoHFW, Feb 2026) · shared with a spouse also 70+; hospital care only · screenshot: result for a 74-year-old</a:t>
-            </a:r>
-            <a:endParaRPr lang="en-US" sz="1050" dirty="0"/>
-          </a:p>
-        </p:txBody>
-      </p:sp>
       <p:pic>
         <p:nvPicPr>
-          <p:cNvPr id="13" name="Sahayak's benefits result for a 74-year-old" descr="Screenshot: Sahayak's benefits result for a 74-year-old">    </p:cNvPr>
+          <p:cNvPr id="12" name="Sahayak's benefits result for a 74-year-old" descr="Screenshot: Sahayak's benefits result for a 74-year-old">    </p:cNvPr>
           <p:cNvPicPr>
             <a:picLocks noChangeAspect="1"/>
           </p:cNvPicPr>
@@ -8840,45 +8489,6 @@
           </a:p>
         </p:txBody>
       </p:sp>
-      <p:sp>
-        <p:nvSpPr>
-          <p:cNvPr id="17" name="source"/>
-          <p:cNvSpPr txBox="1"/>
-          <p:nvPr/>
-        </p:nvSpPr>
-        <p:spPr>
-          <a:xfrm>
-            <a:off x="822960" y="6400800"/>
-            <a:ext cx="10545775" cy="256032"/>
-          </a:xfrm>
-          <a:prstGeom prst="rect">
-            <a:avLst/>
-          </a:prstGeom>
-          <a:noFill/>
-          <a:ln/>
-        </p:spPr>
-        <p:txBody>
-          <a:bodyPr wrap="square" lIns="0" tIns="0" rIns="0" bIns="0" rtlCol="0" anchor="t"/>
-          <a:lstStyle/>
-          <a:p>
-            <a:pPr indent="0" marL="0">
-              <a:buNone/>
-            </a:pPr>
-            <a:r>
-              <a:rPr lang="en-US" sz="1050" dirty="0">
-                <a:solidFill>
-                  <a:srgbClr val="6E6E73"/>
-                </a:solidFill>
-                <a:latin typeface="Arial" pitchFamily="34" charset="0"/>
-                <a:ea typeface="Arial" pitchFamily="34" charset="-122"/>
-                <a:cs typeface="Arial" pitchFamily="34" charset="-120"/>
-              </a:rPr>
-              <a:t>qwen2.5:3b, zero-shot, on the same 137 real published messages, first runs, 7 Oct 2026. In languages Sahayak can’t read yet, the model caught 14 of 15 scams.</a:t>
-            </a:r>
-            <a:endParaRPr lang="en-US" sz="1050" dirty="0"/>
-          </a:p>
-        </p:txBody>
-      </p:sp>
     </p:spTree>
   </p:cSld>
   <p:clrMapOvr>
@@ -9397,45 +9007,6 @@
               <a:t>real users, and messages from people’s own phones. That’s next.</a:t>
             </a:r>
             <a:endParaRPr lang="en-US" sz="2100" dirty="0"/>
-          </a:p>
-        </p:txBody>
-      </p:sp>
-      <p:sp>
-        <p:nvSpPr>
-          <p:cNvPr id="16" name="source"/>
-          <p:cNvSpPr txBox="1"/>
-          <p:nvPr/>
-        </p:nvSpPr>
-        <p:spPr>
-          <a:xfrm>
-            <a:off x="822960" y="6400800"/>
-            <a:ext cx="10545775" cy="256032"/>
-          </a:xfrm>
-          <a:prstGeom prst="rect">
-            <a:avLst/>
-          </a:prstGeom>
-          <a:noFill/>
-          <a:ln/>
-        </p:spPr>
-        <p:txBody>
-          <a:bodyPr wrap="square" lIns="0" tIns="0" rIns="0" bIns="0" rtlCol="0" anchor="t"/>
-          <a:lstStyle/>
-          <a:p>
-            <a:pPr indent="0" marL="0">
-              <a:buNone/>
-            </a:pPr>
-            <a:r>
-              <a:rPr lang="en-US" sz="1050" dirty="0">
-                <a:solidFill>
-                  <a:srgbClr val="6E6E73"/>
-                </a:solidFill>
-                <a:latin typeface="Arial" pitchFamily="34" charset="0"/>
-                <a:ea typeface="Arial" pitchFamily="34" charset="-122"/>
-                <a:cs typeface="Arial" pitchFamily="34" charset="-120"/>
-              </a:rPr>
-              <a:t>In Hindi, English and Hinglish: 67 of 97 scams caught, 11 of 34 genuine flagged; published by the Income Tax portal, PIB Fact Check and fact-checkers · first runs, bench/results</a:t>
-            </a:r>
-            <a:endParaRPr lang="en-US" sz="1050" dirty="0"/>
           </a:p>
         </p:txBody>
       </p:sp>

</xml_diff>